<commit_message>
w5 slides, worksheets and Canvas links
- Week 5: new slide deck; worksheet steps for students who did not reach Exercises 4.1.2 and 4.2
- Worksheets 1–5: 2026 versions with figures checked against the data and interpretations corrected; Week 4 exercises worked out
- Week 3: explorer tool on adjusting for homicide rates, quiz question 7 revised, fourth card on slide 30
- Explorers: helper functions annotated; Week 5 histogram bins fixed
- Readings, Data page and Worksheet 5: Canvas links built from the course number in _variables.yml
- Draft pages from Materials/2026 and an Office lock file removed
</commit_message>
<xml_diff>
--- a/Materials/Slides/slides_w3.pptx
+++ b/Materials/Slides/slides_w3.pptx
@@ -7388,7 +7388,7 @@
           <a:lstStyle/>
           <a:p>
             <a:r>
-              <a:t>The Week 3 Interactive Explorer page (https://cgmoreh.github.io/SOC2069-QUANT-26/Materials/Explorers/explorer_w3.html) has interactive versions of ideas from this lecture. Students can scan the code or follow the link from the course site and try the three tasks on the slide.</a:t>
+              <a:t>The Week 3 Interactive Explorer page (https://cgmoreh.github.io/SOC2069-QUANT-26/Materials/Explorers/explorer_w3.html) has interactive versions of ideas from this lecture. Students can scan the code or follow the link from the course site and try the four tasks on the slide. The fourth rebuilds the inequality coefficient of the two-predictor model (−7.15) from three simple regressions, following Allison (1998, pp. 109–112).</a:t>
             </a:r>
           </a:p>
         </p:txBody>
@@ -34521,7 +34521,7 @@
         <p:spPr>
           <a:xfrm>
             <a:off x="4526280" y="1417320"/>
-            <a:ext cx="6839712" cy="1097280"/>
+            <a:ext cx="6839712" cy="1026000"/>
           </a:xfrm>
           <a:prstGeom prst="roundRect">
             <a:avLst>
@@ -34551,7 +34551,7 @@
         </p:nvSpPr>
         <p:spPr>
           <a:xfrm>
-            <a:off x="4732020" y="1714500"/>
+            <a:off x="4732020" y="1678860"/>
             <a:ext cx="502920" cy="502920"/>
           </a:xfrm>
           <a:prstGeom prst="ellipse">
@@ -34589,7 +34589,7 @@
         </p:nvSpPr>
         <p:spPr>
           <a:xfrm>
-            <a:off x="5440680" y="1527048"/>
+            <a:off x="5440680" y="1491408"/>
             <a:ext cx="5760720" cy="877824"/>
           </a:xfrm>
           <a:prstGeom prst="rect">
@@ -34640,8 +34640,8 @@
         </p:nvSpPr>
         <p:spPr>
           <a:xfrm>
-            <a:off x="4526280" y="2651760"/>
-            <a:ext cx="6839712" cy="1097280"/>
+            <a:off x="4526280" y="2569320"/>
+            <a:ext cx="6839712" cy="1026000"/>
           </a:xfrm>
           <a:prstGeom prst="roundRect">
             <a:avLst>
@@ -34671,7 +34671,7 @@
         </p:nvSpPr>
         <p:spPr>
           <a:xfrm>
-            <a:off x="4732020" y="2948940"/>
+            <a:off x="4732020" y="2830860"/>
             <a:ext cx="502920" cy="502920"/>
           </a:xfrm>
           <a:prstGeom prst="ellipse">
@@ -34709,7 +34709,7 @@
         </p:nvSpPr>
         <p:spPr>
           <a:xfrm>
-            <a:off x="5440680" y="2761488"/>
+            <a:off x="5440680" y="2643408"/>
             <a:ext cx="5760720" cy="877824"/>
           </a:xfrm>
           <a:prstGeom prst="rect">
@@ -34760,8 +34760,8 @@
         </p:nvSpPr>
         <p:spPr>
           <a:xfrm>
-            <a:off x="4526280" y="3886200"/>
-            <a:ext cx="6839712" cy="1097280"/>
+            <a:off x="4526280" y="3721320"/>
+            <a:ext cx="6839712" cy="1026000"/>
           </a:xfrm>
           <a:prstGeom prst="roundRect">
             <a:avLst>
@@ -34791,7 +34791,7 @@
         </p:nvSpPr>
         <p:spPr>
           <a:xfrm>
-            <a:off x="4732020" y="4183379"/>
+            <a:off x="4732020" y="3982860"/>
             <a:ext cx="502920" cy="502920"/>
           </a:xfrm>
           <a:prstGeom prst="ellipse">
@@ -34829,7 +34829,7 @@
         </p:nvSpPr>
         <p:spPr>
           <a:xfrm>
-            <a:off x="5440680" y="3995928"/>
+            <a:off x="5440680" y="3795408"/>
             <a:ext cx="5760720" cy="877824"/>
           </a:xfrm>
           <a:prstGeom prst="rect">
@@ -34874,19 +34874,48 @@
       </p:sp>
       <p:sp>
         <p:nvSpPr>
-          <p:cNvPr id="17" name="Rounded Rectangle 16"/>
+          <p:cNvPr id="19" name="Rounded Rectangle 18"/>
           <p:cNvSpPr/>
           <p:nvPr/>
         </p:nvSpPr>
         <p:spPr>
           <a:xfrm>
-            <a:off x="4526280" y="5120640"/>
-            <a:ext cx="6839712" cy="731520"/>
+            <a:off x="4526280" y="4873320"/>
+            <a:ext cx="6839712" cy="1026000"/>
           </a:xfrm>
           <a:prstGeom prst="roundRect">
             <a:avLst>
               <a:gd name="adj" fmla="val 8000"/>
             </a:avLst>
+          </a:prstGeom>
+          <a:solidFill>
+            <a:srgbClr val="EEF3F7"/>
+          </a:solidFill>
+          <a:ln>
+            <a:noFill/>
+          </a:ln>
+        </p:spPr>
+        <p:txBody>
+          <a:bodyPr rtlCol="0" anchor="ctr"/>
+          <a:lstStyle/>
+          <a:p>
+            <a:pPr algn="ctr"/>
+          </a:p>
+        </p:txBody>
+      </p:sp>
+      <p:sp>
+        <p:nvSpPr>
+          <p:cNvPr id="20" name="Oval 19"/>
+          <p:cNvSpPr/>
+          <p:nvPr/>
+        </p:nvSpPr>
+        <p:spPr>
+          <a:xfrm>
+            <a:off x="4732020" y="5134860"/>
+            <a:ext cx="502920" cy="502920"/>
+          </a:xfrm>
+          <a:prstGeom prst="ellipse">
+            <a:avLst/>
           </a:prstGeom>
           <a:solidFill>
             <a:srgbClr val="1F394D"/>
@@ -34896,6 +34925,97 @@
           </a:ln>
         </p:spPr>
         <p:txBody>
+          <a:bodyPr rtlCol="0" anchor="ctr" wrap="square" lIns="0" rIns="0" tIns="18288" bIns="18288"/>
+          <a:lstStyle/>
+          <a:p>
+            <a:pPr algn="ctr"/>
+            <a:r>
+              <a:rPr sz="1800" b="1" i="0">
+                <a:solidFill>
+                  <a:srgbClr val="FFFFFF"/>
+                </a:solidFill>
+              </a:rPr>
+              <a:t>4</a:t>
+            </a:r>
+            <a:endParaRPr sz="1800"/>
+          </a:p>
+        </p:txBody>
+      </p:sp>
+      <p:sp>
+        <p:nvSpPr>
+          <p:cNvPr id="21" name="TextBox 20"/>
+          <p:cNvSpPr txBox="1"/>
+          <p:nvPr/>
+        </p:nvSpPr>
+        <p:spPr>
+          <a:xfrm>
+            <a:off x="5440680" y="4947408"/>
+            <a:ext cx="5760720" cy="877824"/>
+          </a:xfrm>
+          <a:prstGeom prst="rect">
+            <a:avLst/>
+          </a:prstGeom>
+          <a:noFill/>
+        </p:spPr>
+        <p:txBody>
+          <a:bodyPr wrap="square" lIns="0" rIns="0" tIns="0" bIns="0" anchor="ctr">
+            <a:spAutoFit/>
+          </a:bodyPr>
+          <a:lstStyle/>
+          <a:p>
+            <a:pPr algn="l">
+              <a:spcAft>
+                <a:spcPts val="200"/>
+              </a:spcAft>
+            </a:pPr>
+            <a:r>
+              <a:rPr sz="1800" b="1" i="0">
+                <a:solidFill>
+                  <a:srgbClr val="1F394D"/>
+                </a:solidFill>
+              </a:rPr>
+              <a:t>Adjusting for homicide rates</a:t>
+            </a:r>
+            <a:endParaRPr sz="1800"/>
+          </a:p>
+          <a:p>
+            <a:pPr algn="l"/>
+            <a:r>
+              <a:rPr sz="1500" b="0" i="0">
+                <a:solidFill>
+                  <a:srgbClr val="1F2A33"/>
+                </a:solidFill>
+              </a:rPr>
+              <a:t>Rebuild the coefficient of −7.15 from three simple regressions, following one country through each step.</a:t>
+            </a:r>
+            <a:endParaRPr sz="1500"/>
+          </a:p>
+        </p:txBody>
+      </p:sp>
+      <p:sp>
+        <p:nvSpPr>
+          <p:cNvPr id="17" name="Rounded Rectangle 16"/>
+          <p:cNvSpPr/>
+          <p:nvPr/>
+        </p:nvSpPr>
+        <p:spPr>
+          <a:xfrm>
+            <a:off x="758952" y="5040000"/>
+            <a:ext cx="3429000" cy="859320"/>
+          </a:xfrm>
+          <a:prstGeom prst="roundRect">
+            <a:avLst>
+              <a:gd name="adj" fmla="val 8000"/>
+            </a:avLst>
+          </a:prstGeom>
+          <a:solidFill>
+            <a:srgbClr val="1F394D"/>
+          </a:solidFill>
+          <a:ln>
+            <a:noFill/>
+          </a:ln>
+        </p:spPr>
+        <p:txBody>
           <a:bodyPr rtlCol="0" anchor="ctr"/>
           <a:lstStyle/>
           <a:p>
@@ -34911,8 +35031,8 @@
         </p:nvSpPr>
         <p:spPr>
           <a:xfrm>
-            <a:off x="4754880" y="5120640"/>
-            <a:ext cx="6400800" cy="731520"/>
+            <a:off x="902952" y="5040000"/>
+            <a:ext cx="3141000" cy="859320"/>
           </a:xfrm>
           <a:prstGeom prst="rect">
             <a:avLst/>

</xml_diff>